<commit_message>
Deck: drop the footer text and the small colored dots beside headings
</commit_message>
<xml_diff>
--- a/docs/team-meeting/agents-presentation-2026-10-24.pptx
+++ b/docs/team-meeting/agents-presentation-2026-10-24.pptx
@@ -112,7 +112,7 @@
   <p:extLst>
     <p:ext uri="{521415D9-36F7-43E2-AB2F-B90AF26B5E84}">
       <p14:sectionLst xmlns:p14="http://schemas.microsoft.com/office/powerpoint/2010/main">
-        <p14:section name="Agent layer" id="{0aa1dcb2-a122-b395-fdf3-c9d8a57fd2e4}">
+        <p14:section name="Agent layer" id="{92dc53b1-86ec-a9d4-8732-daa92143858d}">
           <p14:sldIdLst>
             <p14:sldId id="256"/>
             <p14:sldId id="257"/>
@@ -1125,42 +1125,6 @@
             <a:prstDash val="solid"/>
           </a:ln>
         </p:spPr>
-      </p:sp>
-      <p:sp>
-        <p:nvSpPr>
-          <p:cNvPr id="4" name="Text 1"/>
-          <p:cNvSpPr/>
-          <p:nvPr/>
-        </p:nvSpPr>
-        <p:spPr>
-          <a:xfrm>
-            <a:off x="457200" y="6492240"/>
-            <a:ext cx="6400800" cy="274320"/>
-          </a:xfrm>
-          <a:prstGeom prst="rect">
-            <a:avLst/>
-          </a:prstGeom>
-          <a:noFill/>
-          <a:ln/>
-        </p:spPr>
-        <p:txBody>
-          <a:bodyPr wrap="square" lIns="0" tIns="0" rIns="0" bIns="0" rtlCol="0" anchor="ctr"/>
-          <a:lstStyle/>
-          <a:p>
-            <a:pPr indent="0" marL="0">
-              <a:buNone/>
-            </a:pPr>
-            <a:r>
-              <a:rPr lang="en-US" sz="1000" dirty="0">
-                <a:solidFill>
-                  <a:srgbClr val="64748B"/>
-                </a:solidFill>
-              </a:rPr>
-              <a:t>RoadGuard - the AI agent layer</a:t>
-            </a:r>
-            <a:endParaRPr lang="en-US" sz="1000" dirty="0"/>
-          </a:p>
-        </p:txBody>
       </p:sp>
       <p:sp>
         <p:nvSpPr>
@@ -3401,39 +3365,14 @@
       </p:sp>
       <p:sp>
         <p:nvSpPr>
-          <p:cNvPr id="4" name="Dot Agent guardrails"/>
-          <p:cNvSpPr/>
-          <p:nvPr/>
-        </p:nvSpPr>
-        <p:spPr>
-          <a:xfrm>
-            <a:off x="685800" y="1417320"/>
-            <a:ext cx="384048" cy="384048"/>
-          </a:xfrm>
-          <a:prstGeom prst="ellipse">
-            <a:avLst/>
-          </a:prstGeom>
-          <a:solidFill>
-            <a:srgbClr val="16A34A"/>
-          </a:solidFill>
-          <a:ln w="12700">
-            <a:solidFill>
-              <a:srgbClr val="16A34A"/>
-            </a:solidFill>
-            <a:prstDash val="solid"/>
-          </a:ln>
-        </p:spPr>
-      </p:sp>
-      <p:sp>
-        <p:nvSpPr>
-          <p:cNvPr id="5" name="Head Agent guardrails"/>
+          <p:cNvPr id="4" name="Head Agent guardrails"/>
           <p:cNvSpPr txBox="1"/>
           <p:nvPr/>
         </p:nvSpPr>
         <p:spPr>
           <a:xfrm>
-            <a:off x="1188720" y="1371600"/>
-            <a:ext cx="2743200" cy="502920"/>
+            <a:off x="685800" y="1371600"/>
+            <a:ext cx="3383280" cy="502920"/>
           </a:xfrm>
           <a:prstGeom prst="rect">
             <a:avLst/>
@@ -3462,7 +3401,7 @@
       </p:sp>
       <p:sp>
         <p:nvSpPr>
-          <p:cNvPr id="6" name="Items Agent guardrails"/>
+          <p:cNvPr id="5" name="Items Agent guardrails"/>
           <p:cNvSpPr txBox="1"/>
           <p:nvPr/>
         </p:nvSpPr>
@@ -3592,7 +3531,7 @@
       </p:sp>
       <p:sp>
         <p:nvSpPr>
-          <p:cNvPr id="7" name="Col Security"/>
+          <p:cNvPr id="6" name="Col Security"/>
           <p:cNvSpPr/>
           <p:nvPr/>
         </p:nvSpPr>
@@ -3619,39 +3558,14 @@
       </p:sp>
       <p:sp>
         <p:nvSpPr>
-          <p:cNvPr id="8" name="Dot Security"/>
-          <p:cNvSpPr/>
-          <p:nvPr/>
-        </p:nvSpPr>
-        <p:spPr>
-          <a:xfrm>
-            <a:off x="4535424" y="1417320"/>
-            <a:ext cx="384048" cy="384048"/>
-          </a:xfrm>
-          <a:prstGeom prst="ellipse">
-            <a:avLst/>
-          </a:prstGeom>
-          <a:solidFill>
-            <a:srgbClr val="DC2626"/>
-          </a:solidFill>
-          <a:ln w="12700">
-            <a:solidFill>
-              <a:srgbClr val="DC2626"/>
-            </a:solidFill>
-            <a:prstDash val="solid"/>
-          </a:ln>
-        </p:spPr>
-      </p:sp>
-      <p:sp>
-        <p:nvSpPr>
-          <p:cNvPr id="9" name="Head Security"/>
+          <p:cNvPr id="7" name="Head Security"/>
           <p:cNvSpPr txBox="1"/>
           <p:nvPr/>
         </p:nvSpPr>
         <p:spPr>
           <a:xfrm>
-            <a:off x="5038344" y="1371600"/>
-            <a:ext cx="2743200" cy="502920"/>
+            <a:off x="4535424" y="1371600"/>
+            <a:ext cx="3383280" cy="502920"/>
           </a:xfrm>
           <a:prstGeom prst="rect">
             <a:avLst/>
@@ -3680,7 +3594,7 @@
       </p:sp>
       <p:sp>
         <p:nvSpPr>
-          <p:cNvPr id="10" name="Items Security"/>
+          <p:cNvPr id="8" name="Items Security"/>
           <p:cNvSpPr txBox="1"/>
           <p:nvPr/>
         </p:nvSpPr>
@@ -3810,7 +3724,7 @@
       </p:sp>
       <p:sp>
         <p:nvSpPr>
-          <p:cNvPr id="11" name="Col Deterministic shell"/>
+          <p:cNvPr id="9" name="Col Deterministic shell"/>
           <p:cNvSpPr/>
           <p:nvPr/>
         </p:nvSpPr>
@@ -3837,39 +3751,14 @@
       </p:sp>
       <p:sp>
         <p:nvSpPr>
-          <p:cNvPr id="12" name="Dot Deterministic shell"/>
-          <p:cNvSpPr/>
-          <p:nvPr/>
-        </p:nvSpPr>
-        <p:spPr>
-          <a:xfrm>
-            <a:off x="8385048" y="1417320"/>
-            <a:ext cx="384048" cy="384048"/>
-          </a:xfrm>
-          <a:prstGeom prst="ellipse">
-            <a:avLst/>
-          </a:prstGeom>
-          <a:solidFill>
-            <a:srgbClr val="64748B"/>
-          </a:solidFill>
-          <a:ln w="12700">
-            <a:solidFill>
-              <a:srgbClr val="64748B"/>
-            </a:solidFill>
-            <a:prstDash val="solid"/>
-          </a:ln>
-        </p:spPr>
-      </p:sp>
-      <p:sp>
-        <p:nvSpPr>
-          <p:cNvPr id="13" name="Head Deterministic shell"/>
+          <p:cNvPr id="10" name="Head Deterministic shell"/>
           <p:cNvSpPr txBox="1"/>
           <p:nvPr/>
         </p:nvSpPr>
         <p:spPr>
           <a:xfrm>
-            <a:off x="8887968" y="1371600"/>
-            <a:ext cx="2743200" cy="502920"/>
+            <a:off x="8385048" y="1371600"/>
+            <a:ext cx="3383280" cy="502920"/>
           </a:xfrm>
           <a:prstGeom prst="rect">
             <a:avLst/>
@@ -3898,7 +3787,7 @@
       </p:sp>
       <p:sp>
         <p:nvSpPr>
-          <p:cNvPr id="14" name="Items Deterministic shell"/>
+          <p:cNvPr id="11" name="Items Deterministic shell"/>
           <p:cNvSpPr txBox="1"/>
           <p:nvPr/>
         </p:nvSpPr>
@@ -7484,39 +7373,14 @@
       </p:sp>
       <p:sp>
         <p:nvSpPr>
-          <p:cNvPr id="4" name="Dot tradeoffs"/>
-          <p:cNvSpPr/>
-          <p:nvPr/>
-        </p:nvSpPr>
-        <p:spPr>
-          <a:xfrm>
-            <a:off x="685800" y="1463040"/>
-            <a:ext cx="384048" cy="384048"/>
-          </a:xfrm>
-          <a:prstGeom prst="ellipse">
-            <a:avLst/>
-          </a:prstGeom>
-          <a:solidFill>
-            <a:srgbClr val="64748B"/>
-          </a:solidFill>
-          <a:ln w="12700">
-            <a:solidFill>
-              <a:srgbClr val="64748B"/>
-            </a:solidFill>
-            <a:prstDash val="solid"/>
-          </a:ln>
-        </p:spPr>
-      </p:sp>
-      <p:sp>
-        <p:nvSpPr>
-          <p:cNvPr id="5" name="Tradeoffs head"/>
+          <p:cNvPr id="4" name="Tradeoffs head"/>
           <p:cNvSpPr txBox="1"/>
           <p:nvPr/>
         </p:nvSpPr>
         <p:spPr>
           <a:xfrm>
-            <a:off x="1188720" y="1417320"/>
-            <a:ext cx="4663440" cy="502920"/>
+            <a:off x="685800" y="1417320"/>
+            <a:ext cx="5029200" cy="502920"/>
           </a:xfrm>
           <a:prstGeom prst="rect">
             <a:avLst/>
@@ -7545,7 +7409,7 @@
       </p:sp>
       <p:sp>
         <p:nvSpPr>
-          <p:cNvPr id="6" name="Tradeoffs items"/>
+          <p:cNvPr id="5" name="Tradeoffs items"/>
           <p:cNvSpPr txBox="1"/>
           <p:nvPr/>
         </p:nvSpPr>
@@ -7722,7 +7586,7 @@
       </p:sp>
       <p:sp>
         <p:nvSpPr>
-          <p:cNvPr id="7" name="Nextsteps col"/>
+          <p:cNvPr id="6" name="Nextsteps col"/>
           <p:cNvSpPr/>
           <p:nvPr/>
         </p:nvSpPr>
@@ -7749,39 +7613,14 @@
       </p:sp>
       <p:sp>
         <p:nvSpPr>
-          <p:cNvPr id="8" name="Dot next"/>
-          <p:cNvSpPr/>
-          <p:nvPr/>
-        </p:nvSpPr>
-        <p:spPr>
-          <a:xfrm>
-            <a:off x="6473952" y="1463040"/>
-            <a:ext cx="384048" cy="384048"/>
-          </a:xfrm>
-          <a:prstGeom prst="ellipse">
-            <a:avLst/>
-          </a:prstGeom>
-          <a:solidFill>
-            <a:srgbClr val="16A34A"/>
-          </a:solidFill>
-          <a:ln w="12700">
-            <a:solidFill>
-              <a:srgbClr val="16A34A"/>
-            </a:solidFill>
-            <a:prstDash val="solid"/>
-          </a:ln>
-        </p:spPr>
-      </p:sp>
-      <p:sp>
-        <p:nvSpPr>
-          <p:cNvPr id="9" name="Next head"/>
+          <p:cNvPr id="7" name="Next head"/>
           <p:cNvSpPr txBox="1"/>
           <p:nvPr/>
         </p:nvSpPr>
         <p:spPr>
           <a:xfrm>
-            <a:off x="6976872" y="1417320"/>
-            <a:ext cx="4663440" cy="502920"/>
+            <a:off x="6473952" y="1417320"/>
+            <a:ext cx="5029200" cy="502920"/>
           </a:xfrm>
           <a:prstGeom prst="rect">
             <a:avLst/>
@@ -7810,7 +7649,7 @@
       </p:sp>
       <p:sp>
         <p:nvSpPr>
-          <p:cNvPr id="10" name="Next items"/>
+          <p:cNvPr id="8" name="Next items"/>
           <p:cNvSpPr txBox="1"/>
           <p:nvPr/>
         </p:nvSpPr>

</xml_diff>